<commit_message>
Draw the energy chart as shapes so it survives Google Slides
Co-Authored-By: Claude Opus 5.5 <noreply@anthropic.com>
Claude-Session: https://claude.ai/code/session_01XgNmmUgA5WtHmotyWa84KB
</commit_message>
<xml_diff>
--- a/docs/case/SLAM-Ironwood-Template.pptx
+++ b/docs/case/SLAM-Ironwood-Template.pptx
@@ -119,46 +119,46 @@
   <p:extLst>
     <p:ext uri="{521415D9-36F7-43E2-AB2F-B90AF26B5E84}">
       <p14:sectionLst xmlns:p14="http://schemas.microsoft.com/office/powerpoint/2010/main">
-        <p14:section name="Opening" id="{e73a62ba-cb51-34e7-5bab-996319e10748}">
+        <p14:section name="Opening" id="{5854667d-7678-4f2f-d1e3-69dcafd4e7e7}">
           <p14:sldIdLst>
             <p14:sldId id="256"/>
             <p14:sldId id="257"/>
             <p14:sldId id="258"/>
           </p14:sldIdLst>
         </p14:section>
-        <p14:section name="Situation" id="{8e86ec44-051f-eca7-ca28-ca99e888679e}">
+        <p14:section name="Situation" id="{04118bb7-f445-826f-dccd-0baa192ed52e}">
           <p14:sldIdLst>
             <p14:sldId id="259"/>
           </p14:sldIdLst>
         </p14:section>
-        <p14:section name="Options we weighed" id="{ac142e3c-355b-e04e-bbd4-31f501c601f2}">
+        <p14:section name="Options we weighed" id="{88a92f84-8bd3-23ec-e8ab-1daed4fe388b}">
           <p14:sldIdLst>
             <p14:sldId id="260"/>
           </p14:sldIdLst>
         </p14:section>
-        <p14:section name="Financial case" id="{12975f3e-65c1-4d7a-e480-4f41a90aab69}">
+        <p14:section name="Financial case" id="{a02b1e74-6978-9fa8-1f31-8b5141273467}">
           <p14:sldIdLst>
             <p14:sldId id="261"/>
           </p14:sldIdLst>
         </p14:section>
-        <p14:section name="Power and energy" id="{e958676d-aa01-0758-bef6-ed0c2b733e1f}">
+        <p14:section name="Power and energy" id="{30f92020-5d21-d875-8ccc-c2fcf8f1ae34}">
           <p14:sldIdLst>
             <p14:sldId id="262"/>
           </p14:sldIdLst>
         </p14:section>
-        <p14:section name="Community and integrity" id="{d719a9d4-53ee-3b7c-b9ed-0046c09d68a0}">
+        <p14:section name="Community and integrity" id="{94529817-c0e2-1266-42d0-81732c6e2b62}">
           <p14:sldIdLst>
             <p14:sldId id="263"/>
           </p14:sldIdLst>
         </p14:section>
-        <p14:section name="Risks and implementation" id="{c8f1f516-0e9e-4d36-c500-004980797130}">
+        <p14:section name="Risks and implementation" id="{545f37a3-e544-fb74-762a-af092372de9d}">
           <p14:sldIdLst>
             <p14:sldId id="264"/>
             <p14:sldId id="265"/>
             <p14:sldId id="266"/>
           </p14:sldIdLst>
         </p14:section>
-        <p14:section name="Appendix" id="{0606e33a-6ba6-dc08-6c0b-d4d798953774}">
+        <p14:section name="Appendix" id="{f1115b93-23d8-f65a-3784-052345a54d29}">
           <p14:sldIdLst>
             <p14:sldId id="267"/>
             <p14:sldId id="268"/>
@@ -171,333 +171,6 @@
     </p:ext>
   </p:extLst>
 </p:presentation>
-</file>
-
-<file path=ppt/charts/chart1.xml><?xml version="1.0" encoding="utf-8"?>
-<c:chartSpace xmlns:c="http://schemas.openxmlformats.org/drawingml/2006/chart" xmlns:a="http://schemas.openxmlformats.org/drawingml/2006/main" xmlns:r="http://schemas.openxmlformats.org/officeDocument/2006/relationships">
-  <c:date1904 val="0"/>
-  <c:roundedCorners val="1"/>
-  <c:chart>
-    <c:title>
-      <c:tx>
-        <c:rich>
-          <a:bodyPr/>
-          <a:lstStyle/>
-          <a:p>
-            <a:pPr>
-              <a:defRPr sz="1200" b="0" i="0" u="none" strike="noStrike">
-                <a:solidFill>
-                  <a:srgbClr val="56636F"/>
-                </a:solidFill>
-                <a:latin typeface="+mn-lt"/>
-              </a:defRPr>
-            </a:pPr>
-            <a:r>
-              <a:rPr sz="1200" b="0" i="0" u="none" strike="noStrike">
-                <a:solidFill>
-                  <a:srgbClr val="56636F"/>
-                </a:solidFill>
-                <a:latin typeface="+mn-lt"/>
-              </a:rPr>
-              <a:t>Phase 1 energy cost, $ per MWh</a:t>
-            </a:r>
-          </a:p>
-        </c:rich>
-      </c:tx>
-      <c:layout/>
-      <c:overlay val="0"/>
-    </c:title>
-    <c:autoTitleDeleted val="0"/>
-    <c:plotArea>
-      <c:layout/>
-      <c:barChart>
-        <c:barDir val="col"/>
-        <c:grouping val="clustered"/>
-        <c:varyColors val="0"/>
-        <c:ser>
-          <c:idx val="0"/>
-          <c:order val="0"/>
-          <c:tx>
-            <c:strRef>
-              <c:f>Sheet1!$B$1</c:f>
-              <c:strCache>
-                <c:ptCount val="1"/>
-                <c:pt idx="0">
-                  <c:v>Cost per MWh</c:v>
-                </c:pt>
-              </c:strCache>
-            </c:strRef>
-          </c:tx>
-          <c:spPr>
-            <a:solidFill>
-              <a:srgbClr val="8A949C"/>
-            </a:solidFill>
-            <a:effectLst/>
-          </c:spPr>
-          <c:invertIfNegative val="0"/>
-          <c:dLbls>
-            <c:numFmt formatCode="$0.0" sourceLinked="0"/>
-            <c:txPr>
-              <a:bodyPr/>
-              <a:lstStyle/>
-              <a:p>
-                <a:pPr>
-                  <a:defRPr b="0" i="0" strike="noStrike" sz="1200" u="none">
-                    <a:solidFill>
-                      <a:srgbClr val="1C2631"/>
-                    </a:solidFill>
-                    <a:latin typeface="+mn-lt"/>
-                  </a:defRPr>
-                </a:pPr>
-              </a:p>
-            </c:txPr>
-            <c:showLegendKey val="0"/>
-            <c:showVal val="1"/>
-            <c:showCatName val="0"/>
-            <c:showSerName val="0"/>
-            <c:showPercent val="0"/>
-            <c:showBubbleSize val="0"/>
-            <c:showLeaderLines val="0"/>
-          </c:dLbls>
-          <c:dPt>
-            <c:idx val="0"/>
-            <c:invertIfNegative val="0"/>
-            <c:bubble3D val="0"/>
-            <c:spPr>
-              <a:solidFill>
-                <a:srgbClr val="8A949C"/>
-              </a:solidFill>
-              <a:effectLst/>
-            </c:spPr>
-          </c:dPt>
-          <c:dPt>
-            <c:idx val="1"/>
-            <c:invertIfNegative val="0"/>
-            <c:bubble3D val="0"/>
-            <c:spPr>
-              <a:solidFill>
-                <a:srgbClr val="8A949C"/>
-              </a:solidFill>
-              <a:effectLst/>
-            </c:spPr>
-          </c:dPt>
-          <c:dPt>
-            <c:idx val="2"/>
-            <c:invertIfNegative val="0"/>
-            <c:bubble3D val="0"/>
-            <c:spPr>
-              <a:solidFill>
-                <a:srgbClr val="1F5A44"/>
-              </a:solidFill>
-              <a:effectLst/>
-            </c:spPr>
-          </c:dPt>
-          <c:dPt>
-            <c:idx val="3"/>
-            <c:invertIfNegative val="0"/>
-            <c:bubble3D val="0"/>
-            <c:spPr>
-              <a:solidFill>
-                <a:srgbClr val="8A949C"/>
-              </a:solidFill>
-              <a:effectLst/>
-            </c:spPr>
-          </c:dPt>
-          <c:dPt>
-            <c:idx val="4"/>
-            <c:invertIfNegative val="0"/>
-            <c:bubble3D val="0"/>
-            <c:spPr>
-              <a:solidFill>
-                <a:srgbClr val="1F5A44"/>
-              </a:solidFill>
-              <a:effectLst/>
-            </c:spPr>
-          </c:dPt>
-          <c:cat>
-            <c:multiLvlStrRef>
-              <c:f>Sheet1!$A$2:$A$6</c:f>
-              <c:multiLvlStrCache>
-                <c:ptCount val="5"/>
-                <c:lvl>
-                  <c:pt idx="0">
-                    <c:v>Grid only</c:v>
-                  </c:pt>
-                  <c:pt idx="1">
-                    <c:v>Onsite gas</c:v>
-                  </c:pt>
-                  <c:pt idx="2">
-                    <c:v>Grid + clean contracts</c:v>
-                  </c:pt>
-                  <c:pt idx="3">
-                    <c:v>Grid + battery</c:v>
-                  </c:pt>
-                  <c:pt idx="4">
-                    <c:v>Hybrid</c:v>
-                  </c:pt>
-                </c:lvl>
-              </c:multiLvlStrCache>
-            </c:multiLvlStrRef>
-          </c:cat>
-          <c:val>
-            <c:numRef>
-              <c:f>Sheet1!$B$2:$B$6</c:f>
-              <c:numCache>
-                <c:formatCode>General</c:formatCode>
-                <c:ptCount val="5"/>
-                <c:pt idx="0">
-                  <c:v>93.6</c:v>
-                </c:pt>
-                <c:pt idx="1">
-                  <c:v>67.1</c:v>
-                </c:pt>
-                <c:pt idx="2">
-                  <c:v>103.3</c:v>
-                </c:pt>
-                <c:pt idx="3">
-                  <c:v>103.9</c:v>
-                </c:pt>
-                <c:pt idx="4">
-                  <c:v>113.6</c:v>
-                </c:pt>
-              </c:numCache>
-            </c:numRef>
-          </c:val>
-        </c:ser>
-        <c:dLbls>
-          <c:numFmt formatCode="$0.0" sourceLinked="0"/>
-          <c:txPr>
-            <a:bodyPr/>
-            <a:lstStyle/>
-            <a:p>
-              <a:pPr>
-                <a:defRPr b="0" i="0" strike="noStrike" sz="1200" u="none">
-                  <a:solidFill>
-                    <a:srgbClr val="1C2631"/>
-                  </a:solidFill>
-                  <a:latin typeface="+mn-lt"/>
-                </a:defRPr>
-              </a:pPr>
-            </a:p>
-          </c:txPr>
-          <c:showLegendKey val="0"/>
-          <c:showVal val="1"/>
-          <c:showCatName val="0"/>
-          <c:showSerName val="0"/>
-          <c:showPercent val="0"/>
-          <c:showBubbleSize val="0"/>
-          <c:showLeaderLines val="0"/>
-        </c:dLbls>
-        <c:gapWidth val="60"/>
-        <c:overlap val="0"/>
-        <c:axId val="2094734554"/>
-        <c:axId val="2094734552"/>
-        <c:axId val="2094734556"/>
-      </c:barChart>
-      <c:catAx>
-        <c:axId val="2094734554"/>
-        <c:scaling>
-          <c:orientation val="minMax"/>
-        </c:scaling>
-        <c:delete val="0"/>
-        <c:axPos val="b"/>
-        <c:numFmt formatCode="General" sourceLinked="1"/>
-        <c:majorTickMark val="out"/>
-        <c:minorTickMark val="none"/>
-        <c:tickLblPos val="low"/>
-        <c:spPr>
-          <a:ln w="12700" cap="flat">
-            <a:solidFill>
-              <a:srgbClr val="D3D8DC"/>
-            </a:solidFill>
-            <a:prstDash val="solid"/>
-            <a:round/>
-          </a:ln>
-        </c:spPr>
-        <c:txPr>
-          <a:bodyPr/>
-          <a:lstStyle/>
-          <a:p>
-            <a:pPr>
-              <a:defRPr sz="1100" b="0" i="0" u="none" strike="noStrike">
-                <a:solidFill>
-                  <a:srgbClr val="56636F"/>
-                </a:solidFill>
-                <a:latin typeface="+mn-lt"/>
-              </a:defRPr>
-            </a:pPr>
-            <a:endParaRPr lang="en-US"/>
-          </a:p>
-        </c:txPr>
-        <c:crossAx val="2094734552"/>
-        <c:crosses val="autoZero"/>
-        <c:auto val="1"/>
-        <c:lblAlgn val="ctr"/>
-        <c:noMultiLvlLbl val="1"/>
-      </c:catAx>
-      <c:valAx>
-        <c:axId val="2094734552"/>
-        <c:scaling>
-          <c:orientation val="minMax"/>
-          <c:max val="130"/>
-          <c:min val="0"/>
-        </c:scaling>
-        <c:delete val="1"/>
-        <c:axPos val="l"/>
-        <c:numFmt formatCode="General" sourceLinked="0"/>
-        <c:majorTickMark val="out"/>
-        <c:minorTickMark val="none"/>
-        <c:tickLblPos val="nextTo"/>
-        <c:spPr>
-          <a:ln w="12700" cap="flat">
-            <a:solidFill>
-              <a:srgbClr val="888888"/>
-            </a:solidFill>
-            <a:prstDash val="solid"/>
-            <a:round/>
-          </a:ln>
-        </c:spPr>
-        <c:txPr>
-          <a:bodyPr/>
-          <a:lstStyle/>
-          <a:p>
-            <a:pPr>
-              <a:defRPr sz="1200" b="0" i="0" u="none" strike="noStrike">
-                <a:solidFill>
-                  <a:srgbClr val="000000"/>
-                </a:solidFill>
-                <a:latin typeface="Arial"/>
-              </a:defRPr>
-            </a:pPr>
-            <a:endParaRPr lang="en-US"/>
-          </a:p>
-        </c:txPr>
-        <c:crossAx val="2094734554"/>
-        <c:crosses val="autoZero"/>
-        <c:crossBetween val="between"/>
-      </c:valAx>
-      <c:spPr>
-        <a:noFill/>
-        <a:ln>
-          <a:noFill/>
-        </a:ln>
-        <a:effectLst/>
-      </c:spPr>
-    </c:plotArea>
-    <c:plotVisOnly val="1"/>
-    <c:dispBlanksAs val="span"/>
-  </c:chart>
-  <c:spPr>
-    <a:noFill/>
-    <a:ln>
-      <a:noFill/>
-    </a:ln>
-    <a:effectLst/>
-  </c:spPr>
-  <c:externalData r:id="rId1">
-    <c:autoUpdate val="0"/>
-  </c:externalData>
-</c:chartSpace>
 </file>
 
 <file path=ppt/notesMasters/notesMaster1.xml><?xml version="1.0" encoding="utf-8"?>
@@ -2519,59 +2192,6 @@
       <p:sp>
         <p:nvSpPr>
           <p:cNvPr id="3" name="Text 0"/>
-          <p:cNvSpPr/>
-          <p:nvPr>
-            <p:ph idx="101" type="body" hasCustomPrompt="1"/>
-          </p:nvPr>
-        </p:nvSpPr>
-        <p:spPr>
-          <a:xfrm>
-            <a:off x="548640" y="1645920"/>
-            <a:ext cx="11091672" cy="4389120"/>
-          </a:xfrm>
-          <a:prstGeom prst="rect">
-            <a:avLst/>
-          </a:prstGeom>
-          <a:noFill/>
-          <a:ln/>
-        </p:spPr>
-        <p:txBody>
-          <a:bodyPr wrap="square" rtlCol="0"/>
-          <a:lstStyle>
-            <a:lvl1pPr indent="0" marL="0">
-              <a:buNone/>
-              <a:defRPr lang="en-US" sz="1600" dirty="0">
-                <a:solidFill>
-                  <a:srgbClr val="1C2631"/>
-                </a:solidFill>
-                <a:latin typeface="Arial" pitchFamily="34" charset="0"/>
-                <a:ea typeface="Arial" pitchFamily="34" charset="-122"/>
-                <a:cs typeface="Arial" pitchFamily="34" charset="-120"/>
-              </a:defRPr>
-            </a:lvl1pPr>
-          </a:lstStyle>
-          <a:p>
-            <a:pPr indent="0" marL="0">
-              <a:buNone/>
-            </a:pPr>
-            <a:r>
-              <a:rPr lang="en-US" sz="1600" dirty="0">
-                <a:solidFill>
-                  <a:srgbClr val="1C2631"/>
-                </a:solidFill>
-                <a:latin typeface="Arial" pitchFamily="34" charset="0"/>
-                <a:ea typeface="Arial" pitchFamily="34" charset="-122"/>
-                <a:cs typeface="Arial" pitchFamily="34" charset="-120"/>
-              </a:rPr>
-              <a:t>Body</a:t>
-            </a:r>
-            <a:endParaRPr lang="en-US" sz="1600" dirty="0"/>
-          </a:p>
-        </p:txBody>
-      </p:sp>
-      <p:sp>
-        <p:nvSpPr>
-          <p:cNvPr id="4" name="Text 0"/>
           <p:cNvSpPr/>
           <p:nvPr/>
         </p:nvSpPr>
@@ -3936,36 +3556,6 @@
       </p:sp>
       <p:sp>
         <p:nvSpPr>
-          <p:cNvPr id="29" name="Text 0"/>
-          <p:cNvSpPr/>
-          <p:nvPr>
-            <p:ph idx="101" type="body" hasCustomPrompt="1"/>
-          </p:nvPr>
-        </p:nvSpPr>
-        <p:spPr>
-          <a:xfrm>
-            <a:off x="548640" y="1645920"/>
-            <a:ext cx="11091672" cy="4389120"/>
-          </a:xfrm>
-          <a:prstGeom prst="rect">
-            <a:avLst/>
-          </a:prstGeom>
-          <a:noFill/>
-          <a:ln/>
-        </p:spPr>
-        <p:txBody>
-          <a:bodyPr wrap="square" lIns="0" tIns="0" rIns="0" bIns="0" rtlCol="0" anchor="t"/>
-          <a:lstStyle/>
-          <a:p>
-            <a:pPr indent="0" marL="0">
-              <a:buNone/>
-            </a:pPr>
-            <a:endParaRPr lang="en-US" sz="1600" dirty="0"/>
-          </a:p>
-        </p:txBody>
-      </p:sp>
-      <p:sp>
-        <p:nvSpPr>
           <p:cNvPr id="25" name="Slide Number Placeholder 0"/>
           <p:cNvSpPr>
             <a:spLocks noGrp="1"/>
@@ -4679,36 +4269,6 @@
       </p:sp>
       <p:sp>
         <p:nvSpPr>
-          <p:cNvPr id="6" name="Text 0"/>
-          <p:cNvSpPr/>
-          <p:nvPr>
-            <p:ph idx="101" type="body" hasCustomPrompt="1"/>
-          </p:nvPr>
-        </p:nvSpPr>
-        <p:spPr>
-          <a:xfrm>
-            <a:off x="548640" y="1645920"/>
-            <a:ext cx="11091672" cy="4389120"/>
-          </a:xfrm>
-          <a:prstGeom prst="rect">
-            <a:avLst/>
-          </a:prstGeom>
-          <a:noFill/>
-          <a:ln/>
-        </p:spPr>
-        <p:txBody>
-          <a:bodyPr wrap="square" lIns="0" tIns="0" rIns="0" bIns="0" rtlCol="0" anchor="t"/>
-          <a:lstStyle/>
-          <a:p>
-            <a:pPr indent="0" marL="0">
-              <a:buNone/>
-            </a:pPr>
-            <a:endParaRPr lang="en-US" sz="1600" dirty="0"/>
-          </a:p>
-        </p:txBody>
-      </p:sp>
-      <p:sp>
-        <p:nvSpPr>
           <p:cNvPr id="25" name="Slide Number Placeholder 0"/>
           <p:cNvSpPr>
             <a:spLocks noGrp="1"/>
@@ -5341,36 +4901,6 @@
       </p:sp>
       <p:sp>
         <p:nvSpPr>
-          <p:cNvPr id="19" name="Text 0"/>
-          <p:cNvSpPr/>
-          <p:nvPr>
-            <p:ph idx="101" type="body" hasCustomPrompt="1"/>
-          </p:nvPr>
-        </p:nvSpPr>
-        <p:spPr>
-          <a:xfrm>
-            <a:off x="548640" y="1645920"/>
-            <a:ext cx="11091672" cy="4389120"/>
-          </a:xfrm>
-          <a:prstGeom prst="rect">
-            <a:avLst/>
-          </a:prstGeom>
-          <a:noFill/>
-          <a:ln/>
-        </p:spPr>
-        <p:txBody>
-          <a:bodyPr wrap="square" lIns="0" tIns="0" rIns="0" bIns="0" rtlCol="0" anchor="t"/>
-          <a:lstStyle/>
-          <a:p>
-            <a:pPr indent="0" marL="0">
-              <a:buNone/>
-            </a:pPr>
-            <a:endParaRPr lang="en-US" sz="1600" dirty="0"/>
-          </a:p>
-        </p:txBody>
-      </p:sp>
-      <p:sp>
-        <p:nvSpPr>
           <p:cNvPr id="25" name="Slide Number Placeholder 0"/>
           <p:cNvSpPr>
             <a:spLocks noGrp="1"/>
@@ -6348,36 +5878,6 @@
       </p:sp>
       <p:sp>
         <p:nvSpPr>
-          <p:cNvPr id="29" name="Text 0"/>
-          <p:cNvSpPr/>
-          <p:nvPr>
-            <p:ph idx="101" type="body" hasCustomPrompt="1"/>
-          </p:nvPr>
-        </p:nvSpPr>
-        <p:spPr>
-          <a:xfrm>
-            <a:off x="548640" y="1645920"/>
-            <a:ext cx="11091672" cy="4389120"/>
-          </a:xfrm>
-          <a:prstGeom prst="rect">
-            <a:avLst/>
-          </a:prstGeom>
-          <a:noFill/>
-          <a:ln/>
-        </p:spPr>
-        <p:txBody>
-          <a:bodyPr wrap="square" lIns="0" tIns="0" rIns="0" bIns="0" rtlCol="0" anchor="t"/>
-          <a:lstStyle/>
-          <a:p>
-            <a:pPr indent="0" marL="0">
-              <a:buNone/>
-            </a:pPr>
-            <a:endParaRPr lang="en-US" sz="1600" dirty="0"/>
-          </a:p>
-        </p:txBody>
-      </p:sp>
-      <p:sp>
-        <p:nvSpPr>
           <p:cNvPr id="25" name="Slide Number Placeholder 0"/>
           <p:cNvSpPr>
             <a:spLocks noGrp="1"/>
@@ -7161,36 +6661,6 @@
               <a:t>10%</a:t>
             </a:r>
             <a:endParaRPr lang="en-US" sz="2200" dirty="0"/>
-          </a:p>
-        </p:txBody>
-      </p:sp>
-      <p:sp>
-        <p:nvSpPr>
-          <p:cNvPr id="23" name="Text 0"/>
-          <p:cNvSpPr/>
-          <p:nvPr>
-            <p:ph idx="101" type="body" hasCustomPrompt="1"/>
-          </p:nvPr>
-        </p:nvSpPr>
-        <p:spPr>
-          <a:xfrm>
-            <a:off x="548640" y="1645920"/>
-            <a:ext cx="11091672" cy="4389120"/>
-          </a:xfrm>
-          <a:prstGeom prst="rect">
-            <a:avLst/>
-          </a:prstGeom>
-          <a:noFill/>
-          <a:ln/>
-        </p:spPr>
-        <p:txBody>
-          <a:bodyPr wrap="square" lIns="0" tIns="0" rIns="0" bIns="0" rtlCol="0" anchor="t"/>
-          <a:lstStyle/>
-          <a:p>
-            <a:pPr indent="0" marL="0">
-              <a:buNone/>
-            </a:pPr>
-            <a:endParaRPr lang="en-US" sz="1600" dirty="0"/>
           </a:p>
         </p:txBody>
       </p:sp>
@@ -8576,36 +8046,6 @@
       </p:sp>
       <p:sp>
         <p:nvSpPr>
-          <p:cNvPr id="7" name="Text 0"/>
-          <p:cNvSpPr/>
-          <p:nvPr>
-            <p:ph idx="101" type="body" hasCustomPrompt="1"/>
-          </p:nvPr>
-        </p:nvSpPr>
-        <p:spPr>
-          <a:xfrm>
-            <a:off x="548640" y="1645920"/>
-            <a:ext cx="11091672" cy="4389120"/>
-          </a:xfrm>
-          <a:prstGeom prst="rect">
-            <a:avLst/>
-          </a:prstGeom>
-          <a:noFill/>
-          <a:ln/>
-        </p:spPr>
-        <p:txBody>
-          <a:bodyPr wrap="square" lIns="0" tIns="0" rIns="0" bIns="0" rtlCol="0" anchor="t"/>
-          <a:lstStyle/>
-          <a:p>
-            <a:pPr indent="0" marL="0">
-              <a:buNone/>
-            </a:pPr>
-            <a:endParaRPr lang="en-US" sz="1600" dirty="0"/>
-          </a:p>
-        </p:txBody>
-      </p:sp>
-      <p:sp>
-        <p:nvSpPr>
           <p:cNvPr id="25" name="Slide Number Placeholder 0"/>
           <p:cNvSpPr>
             <a:spLocks noGrp="1"/>
@@ -9813,36 +9253,6 @@
       </p:sp>
       <p:sp>
         <p:nvSpPr>
-          <p:cNvPr id="9" name="Text 0"/>
-          <p:cNvSpPr/>
-          <p:nvPr>
-            <p:ph idx="101" type="body" hasCustomPrompt="1"/>
-          </p:nvPr>
-        </p:nvSpPr>
-        <p:spPr>
-          <a:xfrm>
-            <a:off x="548640" y="1645920"/>
-            <a:ext cx="11091672" cy="4389120"/>
-          </a:xfrm>
-          <a:prstGeom prst="rect">
-            <a:avLst/>
-          </a:prstGeom>
-          <a:noFill/>
-          <a:ln/>
-        </p:spPr>
-        <p:txBody>
-          <a:bodyPr wrap="square" lIns="0" tIns="0" rIns="0" bIns="0" rtlCol="0" anchor="t"/>
-          <a:lstStyle/>
-          <a:p>
-            <a:pPr indent="0" marL="0">
-              <a:buNone/>
-            </a:pPr>
-            <a:endParaRPr lang="en-US" sz="1600" dirty="0"/>
-          </a:p>
-        </p:txBody>
-      </p:sp>
-      <p:sp>
-        <p:nvSpPr>
           <p:cNvPr id="25" name="Slide Number Placeholder 0"/>
           <p:cNvSpPr>
             <a:spLocks noGrp="1"/>
@@ -9955,25 +9365,561 @@
           </a:p>
         </p:txBody>
       </p:sp>
-      <p:graphicFrame>
-        <p:nvGraphicFramePr>
-          <p:cNvPr id="3" name="Energy cost chart" descr=""/>
-          <p:cNvGraphicFramePr/>
-          <p:nvPr/>
-        </p:nvGraphicFramePr>
-        <p:xfrm>
-          <a:off x="548640" y="1600200"/>
-          <a:ext cx="7223760" cy="4251960"/>
-        </p:xfrm>
-        <a:graphic xmlns:a="http://schemas.openxmlformats.org/drawingml/2006/main">
-          <a:graphicData uri="http://schemas.openxmlformats.org/drawingml/2006/chart">
-            <c:chart xmlns:c="http://schemas.openxmlformats.org/drawingml/2006/chart" r:id="rId1"/>
-          </a:graphicData>
-        </a:graphic>
-      </p:graphicFrame>
-      <p:sp>
-        <p:nvSpPr>
-          <p:cNvPr id="4" name="Takeaway panel"/>
+      <p:sp>
+        <p:nvSpPr>
+          <p:cNvPr id="3" name="Chart title"/>
+          <p:cNvSpPr txBox="1"/>
+          <p:nvPr/>
+        </p:nvSpPr>
+        <p:spPr>
+          <a:xfrm>
+            <a:off x="548640" y="1645920"/>
+            <a:ext cx="7223760" cy="320040"/>
+          </a:xfrm>
+          <a:prstGeom prst="rect">
+            <a:avLst/>
+          </a:prstGeom>
+          <a:noFill/>
+          <a:ln/>
+        </p:spPr>
+        <p:txBody>
+          <a:bodyPr wrap="square" lIns="0" tIns="0" rIns="0" bIns="0" rtlCol="0" anchor="t"/>
+          <a:lstStyle/>
+          <a:p>
+            <a:pPr indent="0" marL="0">
+              <a:buNone/>
+            </a:pPr>
+            <a:r>
+              <a:rPr lang="en-US" sz="1200" dirty="0">
+                <a:solidFill>
+                  <a:srgbClr val="56636F"/>
+                </a:solidFill>
+                <a:latin typeface="Arial" pitchFamily="34" charset="0"/>
+                <a:ea typeface="Arial" pitchFamily="34" charset="-122"/>
+                <a:cs typeface="Arial" pitchFamily="34" charset="-120"/>
+              </a:rPr>
+              <a:t>Phase 1 energy cost, $ per MWh</a:t>
+            </a:r>
+            <a:endParaRPr lang="en-US" sz="1200" dirty="0"/>
+          </a:p>
+        </p:txBody>
+      </p:sp>
+      <p:sp>
+        <p:nvSpPr>
+          <p:cNvPr id="4" name="Bar Grid only"/>
+          <p:cNvSpPr/>
+          <p:nvPr/>
+        </p:nvSpPr>
+        <p:spPr>
+          <a:xfrm>
+            <a:off x="777240" y="2884546"/>
+            <a:ext cx="960120" cy="2373254"/>
+          </a:xfrm>
+          <a:prstGeom prst="rect">
+            <a:avLst/>
+          </a:prstGeom>
+          <a:solidFill>
+            <a:srgbClr val="8A949C"/>
+          </a:solidFill>
+          <a:ln/>
+        </p:spPr>
+      </p:sp>
+      <p:sp>
+        <p:nvSpPr>
+          <p:cNvPr id="5" name="Text 3"/>
+          <p:cNvSpPr txBox="1"/>
+          <p:nvPr/>
+        </p:nvSpPr>
+        <p:spPr>
+          <a:xfrm>
+            <a:off x="594360" y="2537074"/>
+            <a:ext cx="1325880" cy="292608"/>
+          </a:xfrm>
+          <a:prstGeom prst="rect">
+            <a:avLst/>
+          </a:prstGeom>
+          <a:noFill/>
+          <a:ln/>
+        </p:spPr>
+        <p:txBody>
+          <a:bodyPr wrap="square" lIns="0" tIns="0" rIns="0" bIns="0" rtlCol="0" anchor="t"/>
+          <a:lstStyle/>
+          <a:p>
+            <a:pPr algn="ctr" indent="0" marL="0">
+              <a:buNone/>
+            </a:pPr>
+            <a:r>
+              <a:rPr lang="en-US" sz="1300" b="1" dirty="0">
+                <a:solidFill>
+                  <a:srgbClr val="1C2631"/>
+                </a:solidFill>
+                <a:latin typeface="Arial" pitchFamily="34" charset="0"/>
+                <a:ea typeface="Arial" pitchFamily="34" charset="-122"/>
+                <a:cs typeface="Arial" pitchFamily="34" charset="-120"/>
+              </a:rPr>
+              <a:t>$93.6</a:t>
+            </a:r>
+            <a:endParaRPr lang="en-US" sz="1300" dirty="0"/>
+          </a:p>
+        </p:txBody>
+      </p:sp>
+      <p:sp>
+        <p:nvSpPr>
+          <p:cNvPr id="6" name="Text 4"/>
+          <p:cNvSpPr txBox="1"/>
+          <p:nvPr/>
+        </p:nvSpPr>
+        <p:spPr>
+          <a:xfrm>
+            <a:off x="548640" y="5349240"/>
+            <a:ext cx="1417320" cy="502920"/>
+          </a:xfrm>
+          <a:prstGeom prst="rect">
+            <a:avLst/>
+          </a:prstGeom>
+          <a:noFill/>
+          <a:ln/>
+        </p:spPr>
+        <p:txBody>
+          <a:bodyPr wrap="square" lIns="0" tIns="0" rIns="0" bIns="0" rtlCol="0" anchor="t"/>
+          <a:lstStyle/>
+          <a:p>
+            <a:pPr algn="ctr" indent="0" marL="0">
+              <a:buNone/>
+            </a:pPr>
+            <a:r>
+              <a:rPr lang="en-US" sz="1100" dirty="0">
+                <a:solidFill>
+                  <a:srgbClr val="56636F"/>
+                </a:solidFill>
+                <a:latin typeface="Arial" pitchFamily="34" charset="0"/>
+                <a:ea typeface="Arial" pitchFamily="34" charset="-122"/>
+                <a:cs typeface="Arial" pitchFamily="34" charset="-120"/>
+              </a:rPr>
+              <a:t>Grid only</a:t>
+            </a:r>
+            <a:endParaRPr lang="en-US" sz="1100" dirty="0"/>
+          </a:p>
+        </p:txBody>
+      </p:sp>
+      <p:sp>
+        <p:nvSpPr>
+          <p:cNvPr id="7" name="Bar Onsite gas"/>
+          <p:cNvSpPr/>
+          <p:nvPr/>
+        </p:nvSpPr>
+        <p:spPr>
+          <a:xfrm>
+            <a:off x="2194560" y="3556461"/>
+            <a:ext cx="960120" cy="1701339"/>
+          </a:xfrm>
+          <a:prstGeom prst="rect">
+            <a:avLst/>
+          </a:prstGeom>
+          <a:solidFill>
+            <a:srgbClr val="8A949C"/>
+          </a:solidFill>
+          <a:ln/>
+        </p:spPr>
+      </p:sp>
+      <p:sp>
+        <p:nvSpPr>
+          <p:cNvPr id="8" name="Text 6"/>
+          <p:cNvSpPr txBox="1"/>
+          <p:nvPr/>
+        </p:nvSpPr>
+        <p:spPr>
+          <a:xfrm>
+            <a:off x="2011680" y="3208989"/>
+            <a:ext cx="1325880" cy="292608"/>
+          </a:xfrm>
+          <a:prstGeom prst="rect">
+            <a:avLst/>
+          </a:prstGeom>
+          <a:noFill/>
+          <a:ln/>
+        </p:spPr>
+        <p:txBody>
+          <a:bodyPr wrap="square" lIns="0" tIns="0" rIns="0" bIns="0" rtlCol="0" anchor="t"/>
+          <a:lstStyle/>
+          <a:p>
+            <a:pPr algn="ctr" indent="0" marL="0">
+              <a:buNone/>
+            </a:pPr>
+            <a:r>
+              <a:rPr lang="en-US" sz="1300" b="1" dirty="0">
+                <a:solidFill>
+                  <a:srgbClr val="1C2631"/>
+                </a:solidFill>
+                <a:latin typeface="Arial" pitchFamily="34" charset="0"/>
+                <a:ea typeface="Arial" pitchFamily="34" charset="-122"/>
+                <a:cs typeface="Arial" pitchFamily="34" charset="-120"/>
+              </a:rPr>
+              <a:t>$67.1</a:t>
+            </a:r>
+            <a:endParaRPr lang="en-US" sz="1300" dirty="0"/>
+          </a:p>
+        </p:txBody>
+      </p:sp>
+      <p:sp>
+        <p:nvSpPr>
+          <p:cNvPr id="9" name="Text 7"/>
+          <p:cNvSpPr txBox="1"/>
+          <p:nvPr/>
+        </p:nvSpPr>
+        <p:spPr>
+          <a:xfrm>
+            <a:off x="1965960" y="5349240"/>
+            <a:ext cx="1417320" cy="502920"/>
+          </a:xfrm>
+          <a:prstGeom prst="rect">
+            <a:avLst/>
+          </a:prstGeom>
+          <a:noFill/>
+          <a:ln/>
+        </p:spPr>
+        <p:txBody>
+          <a:bodyPr wrap="square" lIns="0" tIns="0" rIns="0" bIns="0" rtlCol="0" anchor="t"/>
+          <a:lstStyle/>
+          <a:p>
+            <a:pPr algn="ctr" indent="0" marL="0">
+              <a:buNone/>
+            </a:pPr>
+            <a:r>
+              <a:rPr lang="en-US" sz="1100" dirty="0">
+                <a:solidFill>
+                  <a:srgbClr val="56636F"/>
+                </a:solidFill>
+                <a:latin typeface="Arial" pitchFamily="34" charset="0"/>
+                <a:ea typeface="Arial" pitchFamily="34" charset="-122"/>
+                <a:cs typeface="Arial" pitchFamily="34" charset="-120"/>
+              </a:rPr>
+              <a:t>Onsite gas</a:t>
+            </a:r>
+            <a:endParaRPr lang="en-US" sz="1100" dirty="0"/>
+          </a:p>
+        </p:txBody>
+      </p:sp>
+      <p:sp>
+        <p:nvSpPr>
+          <p:cNvPr id="10" name="Bar Grid + clean contracts"/>
+          <p:cNvSpPr/>
+          <p:nvPr/>
+        </p:nvSpPr>
+        <p:spPr>
+          <a:xfrm>
+            <a:off x="3611880" y="2638599"/>
+            <a:ext cx="960120" cy="2619201"/>
+          </a:xfrm>
+          <a:prstGeom prst="rect">
+            <a:avLst/>
+          </a:prstGeom>
+          <a:solidFill>
+            <a:srgbClr val="1F5A44"/>
+          </a:solidFill>
+          <a:ln/>
+        </p:spPr>
+      </p:sp>
+      <p:sp>
+        <p:nvSpPr>
+          <p:cNvPr id="11" name="Text 9"/>
+          <p:cNvSpPr txBox="1"/>
+          <p:nvPr/>
+        </p:nvSpPr>
+        <p:spPr>
+          <a:xfrm>
+            <a:off x="3429000" y="2291127"/>
+            <a:ext cx="1325880" cy="292608"/>
+          </a:xfrm>
+          <a:prstGeom prst="rect">
+            <a:avLst/>
+          </a:prstGeom>
+          <a:noFill/>
+          <a:ln/>
+        </p:spPr>
+        <p:txBody>
+          <a:bodyPr wrap="square" lIns="0" tIns="0" rIns="0" bIns="0" rtlCol="0" anchor="t"/>
+          <a:lstStyle/>
+          <a:p>
+            <a:pPr algn="ctr" indent="0" marL="0">
+              <a:buNone/>
+            </a:pPr>
+            <a:r>
+              <a:rPr lang="en-US" sz="1300" b="1" dirty="0">
+                <a:solidFill>
+                  <a:srgbClr val="1C2631"/>
+                </a:solidFill>
+                <a:latin typeface="Arial" pitchFamily="34" charset="0"/>
+                <a:ea typeface="Arial" pitchFamily="34" charset="-122"/>
+                <a:cs typeface="Arial" pitchFamily="34" charset="-120"/>
+              </a:rPr>
+              <a:t>$103.3</a:t>
+            </a:r>
+            <a:endParaRPr lang="en-US" sz="1300" dirty="0"/>
+          </a:p>
+        </p:txBody>
+      </p:sp>
+      <p:sp>
+        <p:nvSpPr>
+          <p:cNvPr id="12" name="Text 10"/>
+          <p:cNvSpPr txBox="1"/>
+          <p:nvPr/>
+        </p:nvSpPr>
+        <p:spPr>
+          <a:xfrm>
+            <a:off x="3383280" y="5349240"/>
+            <a:ext cx="1417320" cy="502920"/>
+          </a:xfrm>
+          <a:prstGeom prst="rect">
+            <a:avLst/>
+          </a:prstGeom>
+          <a:noFill/>
+          <a:ln/>
+        </p:spPr>
+        <p:txBody>
+          <a:bodyPr wrap="square" lIns="0" tIns="0" rIns="0" bIns="0" rtlCol="0" anchor="t"/>
+          <a:lstStyle/>
+          <a:p>
+            <a:pPr algn="ctr" indent="0" marL="0">
+              <a:buNone/>
+            </a:pPr>
+            <a:r>
+              <a:rPr lang="en-US" sz="1100" dirty="0">
+                <a:solidFill>
+                  <a:srgbClr val="56636F"/>
+                </a:solidFill>
+                <a:latin typeface="Arial" pitchFamily="34" charset="0"/>
+                <a:ea typeface="Arial" pitchFamily="34" charset="-122"/>
+                <a:cs typeface="Arial" pitchFamily="34" charset="-120"/>
+              </a:rPr>
+              <a:t>Grid + clean contracts</a:t>
+            </a:r>
+            <a:endParaRPr lang="en-US" sz="1100" dirty="0"/>
+          </a:p>
+        </p:txBody>
+      </p:sp>
+      <p:sp>
+        <p:nvSpPr>
+          <p:cNvPr id="13" name="Bar Grid + battery"/>
+          <p:cNvSpPr/>
+          <p:nvPr/>
+        </p:nvSpPr>
+        <p:spPr>
+          <a:xfrm>
+            <a:off x="5029200" y="2623386"/>
+            <a:ext cx="960120" cy="2634414"/>
+          </a:xfrm>
+          <a:prstGeom prst="rect">
+            <a:avLst/>
+          </a:prstGeom>
+          <a:solidFill>
+            <a:srgbClr val="8A949C"/>
+          </a:solidFill>
+          <a:ln/>
+        </p:spPr>
+      </p:sp>
+      <p:sp>
+        <p:nvSpPr>
+          <p:cNvPr id="14" name="Text 12"/>
+          <p:cNvSpPr txBox="1"/>
+          <p:nvPr/>
+        </p:nvSpPr>
+        <p:spPr>
+          <a:xfrm>
+            <a:off x="4846320" y="2275914"/>
+            <a:ext cx="1325880" cy="292608"/>
+          </a:xfrm>
+          <a:prstGeom prst="rect">
+            <a:avLst/>
+          </a:prstGeom>
+          <a:noFill/>
+          <a:ln/>
+        </p:spPr>
+        <p:txBody>
+          <a:bodyPr wrap="square" lIns="0" tIns="0" rIns="0" bIns="0" rtlCol="0" anchor="t"/>
+          <a:lstStyle/>
+          <a:p>
+            <a:pPr algn="ctr" indent="0" marL="0">
+              <a:buNone/>
+            </a:pPr>
+            <a:r>
+              <a:rPr lang="en-US" sz="1300" b="1" dirty="0">
+                <a:solidFill>
+                  <a:srgbClr val="1C2631"/>
+                </a:solidFill>
+                <a:latin typeface="Arial" pitchFamily="34" charset="0"/>
+                <a:ea typeface="Arial" pitchFamily="34" charset="-122"/>
+                <a:cs typeface="Arial" pitchFamily="34" charset="-120"/>
+              </a:rPr>
+              <a:t>$103.9</a:t>
+            </a:r>
+            <a:endParaRPr lang="en-US" sz="1300" dirty="0"/>
+          </a:p>
+        </p:txBody>
+      </p:sp>
+      <p:sp>
+        <p:nvSpPr>
+          <p:cNvPr id="15" name="Text 13"/>
+          <p:cNvSpPr txBox="1"/>
+          <p:nvPr/>
+        </p:nvSpPr>
+        <p:spPr>
+          <a:xfrm>
+            <a:off x="4800600" y="5349240"/>
+            <a:ext cx="1417320" cy="502920"/>
+          </a:xfrm>
+          <a:prstGeom prst="rect">
+            <a:avLst/>
+          </a:prstGeom>
+          <a:noFill/>
+          <a:ln/>
+        </p:spPr>
+        <p:txBody>
+          <a:bodyPr wrap="square" lIns="0" tIns="0" rIns="0" bIns="0" rtlCol="0" anchor="t"/>
+          <a:lstStyle/>
+          <a:p>
+            <a:pPr algn="ctr" indent="0" marL="0">
+              <a:buNone/>
+            </a:pPr>
+            <a:r>
+              <a:rPr lang="en-US" sz="1100" dirty="0">
+                <a:solidFill>
+                  <a:srgbClr val="56636F"/>
+                </a:solidFill>
+                <a:latin typeface="Arial" pitchFamily="34" charset="0"/>
+                <a:ea typeface="Arial" pitchFamily="34" charset="-122"/>
+                <a:cs typeface="Arial" pitchFamily="34" charset="-120"/>
+              </a:rPr>
+              <a:t>Grid + battery</a:t>
+            </a:r>
+            <a:endParaRPr lang="en-US" sz="1100" dirty="0"/>
+          </a:p>
+        </p:txBody>
+      </p:sp>
+      <p:sp>
+        <p:nvSpPr>
+          <p:cNvPr id="16" name="Bar Hybrid"/>
+          <p:cNvSpPr/>
+          <p:nvPr/>
+        </p:nvSpPr>
+        <p:spPr>
+          <a:xfrm>
+            <a:off x="6446520" y="2377440"/>
+            <a:ext cx="960120" cy="2880360"/>
+          </a:xfrm>
+          <a:prstGeom prst="rect">
+            <a:avLst/>
+          </a:prstGeom>
+          <a:solidFill>
+            <a:srgbClr val="1F5A44"/>
+          </a:solidFill>
+          <a:ln/>
+        </p:spPr>
+      </p:sp>
+      <p:sp>
+        <p:nvSpPr>
+          <p:cNvPr id="17" name="Text 15"/>
+          <p:cNvSpPr txBox="1"/>
+          <p:nvPr/>
+        </p:nvSpPr>
+        <p:spPr>
+          <a:xfrm>
+            <a:off x="6263640" y="2029968"/>
+            <a:ext cx="1325880" cy="292608"/>
+          </a:xfrm>
+          <a:prstGeom prst="rect">
+            <a:avLst/>
+          </a:prstGeom>
+          <a:noFill/>
+          <a:ln/>
+        </p:spPr>
+        <p:txBody>
+          <a:bodyPr wrap="square" lIns="0" tIns="0" rIns="0" bIns="0" rtlCol="0" anchor="t"/>
+          <a:lstStyle/>
+          <a:p>
+            <a:pPr algn="ctr" indent="0" marL="0">
+              <a:buNone/>
+            </a:pPr>
+            <a:r>
+              <a:rPr lang="en-US" sz="1300" b="1" dirty="0">
+                <a:solidFill>
+                  <a:srgbClr val="1C2631"/>
+                </a:solidFill>
+                <a:latin typeface="Arial" pitchFamily="34" charset="0"/>
+                <a:ea typeface="Arial" pitchFamily="34" charset="-122"/>
+                <a:cs typeface="Arial" pitchFamily="34" charset="-120"/>
+              </a:rPr>
+              <a:t>$113.6</a:t>
+            </a:r>
+            <a:endParaRPr lang="en-US" sz="1300" dirty="0"/>
+          </a:p>
+        </p:txBody>
+      </p:sp>
+      <p:sp>
+        <p:nvSpPr>
+          <p:cNvPr id="18" name="Text 16"/>
+          <p:cNvSpPr txBox="1"/>
+          <p:nvPr/>
+        </p:nvSpPr>
+        <p:spPr>
+          <a:xfrm>
+            <a:off x="6217920" y="5349240"/>
+            <a:ext cx="1417320" cy="502920"/>
+          </a:xfrm>
+          <a:prstGeom prst="rect">
+            <a:avLst/>
+          </a:prstGeom>
+          <a:noFill/>
+          <a:ln/>
+        </p:spPr>
+        <p:txBody>
+          <a:bodyPr wrap="square" lIns="0" tIns="0" rIns="0" bIns="0" rtlCol="0" anchor="t"/>
+          <a:lstStyle/>
+          <a:p>
+            <a:pPr algn="ctr" indent="0" marL="0">
+              <a:buNone/>
+            </a:pPr>
+            <a:r>
+              <a:rPr lang="en-US" sz="1100" dirty="0">
+                <a:solidFill>
+                  <a:srgbClr val="56636F"/>
+                </a:solidFill>
+                <a:latin typeface="Arial" pitchFamily="34" charset="0"/>
+                <a:ea typeface="Arial" pitchFamily="34" charset="-122"/>
+                <a:cs typeface="Arial" pitchFamily="34" charset="-120"/>
+              </a:rPr>
+              <a:t>Hybrid</a:t>
+            </a:r>
+            <a:endParaRPr lang="en-US" sz="1100" dirty="0"/>
+          </a:p>
+        </p:txBody>
+      </p:sp>
+      <p:sp>
+        <p:nvSpPr>
+          <p:cNvPr id="19" name="Shape 17"/>
+          <p:cNvSpPr/>
+          <p:nvPr/>
+        </p:nvSpPr>
+        <p:spPr>
+          <a:xfrm>
+            <a:off x="548640" y="5257800"/>
+            <a:ext cx="7223760" cy="0"/>
+          </a:xfrm>
+          <a:prstGeom prst="line">
+            <a:avLst/>
+          </a:prstGeom>
+          <a:noFill/>
+          <a:ln w="12700">
+            <a:solidFill>
+              <a:srgbClr val="B8C0C6"/>
+            </a:solidFill>
+            <a:prstDash val="solid"/>
+          </a:ln>
+        </p:spPr>
+      </p:sp>
+      <p:sp>
+        <p:nvSpPr>
+          <p:cNvPr id="20" name="Takeaway panel"/>
           <p:cNvSpPr/>
           <p:nvPr/>
         </p:nvSpPr>
@@ -9993,7 +9939,7 @@
       </p:sp>
       <p:sp>
         <p:nvSpPr>
-          <p:cNvPr id="5" name="Text 2"/>
+          <p:cNvPr id="21" name="Text 19"/>
           <p:cNvSpPr txBox="1"/>
           <p:nvPr/>
         </p:nvSpPr>
@@ -10032,7 +9978,7 @@
       </p:sp>
       <p:sp>
         <p:nvSpPr>
-          <p:cNvPr id="6" name="Text 3"/>
+          <p:cNvPr id="22" name="Text 20"/>
           <p:cNvSpPr txBox="1"/>
           <p:nvPr/>
         </p:nvSpPr>
@@ -10138,7 +10084,7 @@
       </p:sp>
       <p:sp>
         <p:nvSpPr>
-          <p:cNvPr id="7" name="Source"/>
+          <p:cNvPr id="23" name="Source"/>
           <p:cNvSpPr txBox="1"/>
           <p:nvPr/>
         </p:nvSpPr>
@@ -10172,36 +10118,6 @@
               <a:t>Source: SLAM analysis; PJM 2028/29 auction, EIA, EPA eGRID2023, NREL, PA GRID Standards</a:t>
             </a:r>
             <a:endParaRPr lang="en-US" sz="900" dirty="0"/>
-          </a:p>
-        </p:txBody>
-      </p:sp>
-      <p:sp>
-        <p:nvSpPr>
-          <p:cNvPr id="9" name="Text 0"/>
-          <p:cNvSpPr/>
-          <p:nvPr>
-            <p:ph idx="101" type="body" hasCustomPrompt="1"/>
-          </p:nvPr>
-        </p:nvSpPr>
-        <p:spPr>
-          <a:xfrm>
-            <a:off x="548640" y="1645920"/>
-            <a:ext cx="11091672" cy="4389120"/>
-          </a:xfrm>
-          <a:prstGeom prst="rect">
-            <a:avLst/>
-          </a:prstGeom>
-          <a:noFill/>
-          <a:ln/>
-        </p:spPr>
-        <p:txBody>
-          <a:bodyPr wrap="square" lIns="0" tIns="0" rIns="0" bIns="0" rtlCol="0" anchor="t"/>
-          <a:lstStyle/>
-          <a:p>
-            <a:pPr indent="0" marL="0">
-              <a:buNone/>
-            </a:pPr>
-            <a:endParaRPr lang="en-US" sz="1600" dirty="0"/>
           </a:p>
         </p:txBody>
       </p:sp>
@@ -10805,36 +10721,6 @@
               <a:t>Source: [Case interviews; public comment; team analysis]</a:t>
             </a:r>
             <a:endParaRPr lang="en-US" sz="900" dirty="0"/>
-          </a:p>
-        </p:txBody>
-      </p:sp>
-      <p:sp>
-        <p:nvSpPr>
-          <p:cNvPr id="19" name="Text 0"/>
-          <p:cNvSpPr/>
-          <p:nvPr>
-            <p:ph idx="101" type="body" hasCustomPrompt="1"/>
-          </p:nvPr>
-        </p:nvSpPr>
-        <p:spPr>
-          <a:xfrm>
-            <a:off x="548640" y="1645920"/>
-            <a:ext cx="11091672" cy="4389120"/>
-          </a:xfrm>
-          <a:prstGeom prst="rect">
-            <a:avLst/>
-          </a:prstGeom>
-          <a:noFill/>
-          <a:ln/>
-        </p:spPr>
-        <p:txBody>
-          <a:bodyPr wrap="square" lIns="0" tIns="0" rIns="0" bIns="0" rtlCol="0" anchor="t"/>
-          <a:lstStyle/>
-          <a:p>
-            <a:pPr indent="0" marL="0">
-              <a:buNone/>
-            </a:pPr>
-            <a:endParaRPr lang="en-US" sz="1600" dirty="0"/>
           </a:p>
         </p:txBody>
       </p:sp>
@@ -12206,36 +12092,6 @@
               <a:t>Source: [Team analysis]</a:t>
             </a:r>
             <a:endParaRPr lang="en-US" sz="900" dirty="0"/>
-          </a:p>
-        </p:txBody>
-      </p:sp>
-      <p:sp>
-        <p:nvSpPr>
-          <p:cNvPr id="6" name="Text 0"/>
-          <p:cNvSpPr/>
-          <p:nvPr>
-            <p:ph idx="101" type="body" hasCustomPrompt="1"/>
-          </p:nvPr>
-        </p:nvSpPr>
-        <p:spPr>
-          <a:xfrm>
-            <a:off x="548640" y="1645920"/>
-            <a:ext cx="11091672" cy="4389120"/>
-          </a:xfrm>
-          <a:prstGeom prst="rect">
-            <a:avLst/>
-          </a:prstGeom>
-          <a:noFill/>
-          <a:ln/>
-        </p:spPr>
-        <p:txBody>
-          <a:bodyPr wrap="square" lIns="0" tIns="0" rIns="0" bIns="0" rtlCol="0" anchor="t"/>
-          <a:lstStyle/>
-          <a:p>
-            <a:pPr indent="0" marL="0">
-              <a:buNone/>
-            </a:pPr>
-            <a:endParaRPr lang="en-US" sz="1600" dirty="0"/>
           </a:p>
         </p:txBody>
       </p:sp>

</xml_diff>